<commit_message>
Seguimiento al 30-10: «APK de release» en lugar de «APK firmada», diagramas en StarUML y temas abiertos actualizados
</commit_message>
<xml_diff>
--- a/Fase 2/Seguimiento semanal/Seguimiento_Roadmap_Proyecto_Barberia_30-10.pptx
+++ b/Fase 2/Seguimiento semanal/Seguimiento_Roadmap_Proyecto_Barberia_30-10.pptx
@@ -5,7 +5,7 @@
     <p:sldMasterId id="2147483648" r:id="rId1"/>
   </p:sldMasterIdLst>
   <p:notesMasterIdLst>
-    <p:notesMasterId r:id="rId18"/>
+    <p:notesMasterId r:id="rId17"/>
   </p:notesMasterIdLst>
   <p:sldIdLst>
     <p:sldId id="256" r:id="rId2"/>
@@ -19,10 +19,10 @@
     <p:sldId id="264" r:id="rId10"/>
     <p:sldId id="265" r:id="rId11"/>
     <p:sldId id="266" r:id="rId12"/>
-    <p:sldId id="268" r:id="rId14"/>
-    <p:sldId id="269" r:id="rId15"/>
-    <p:sldId id="270" r:id="rId16"/>
-    <p:sldId id="271" r:id="rId17"/>
+    <p:sldId id="268" r:id="rId13"/>
+    <p:sldId id="269" r:id="rId14"/>
+    <p:sldId id="270" r:id="rId15"/>
+    <p:sldId id="271" r:id="rId16"/>
   </p:sldIdLst>
   <p:sldSz cx="12192000" cy="6858000"/>
   <p:notesSz cx="6858000" cy="12192000"/>
@@ -510,6 +510,92 @@
 </p:notes>
 </file>
 
+<file path=ppt/notesSlides/notesSlide12.xml><?xml version="1.0" encoding="utf-8"?>
+<p:notes xmlns:a="http://schemas.openxmlformats.org/drawingml/2006/main" xmlns:r="http://schemas.openxmlformats.org/officeDocument/2006/relationships" xmlns:p="http://schemas.openxmlformats.org/presentationml/2006/main">
+  <p:cSld>
+    <p:spTree>
+      <p:nvGrpSpPr>
+        <p:cNvPr id="1" name=""/>
+        <p:cNvGrpSpPr/>
+        <p:nvPr/>
+      </p:nvGrpSpPr>
+      <p:grpSpPr>
+        <a:xfrm>
+          <a:off x="0" y="0"/>
+          <a:ext cx="0" cy="0"/>
+          <a:chOff x="0" y="0"/>
+          <a:chExt cx="0" cy="0"/>
+        </a:xfrm>
+      </p:grpSpPr>
+      <p:sp>
+        <p:nvSpPr>
+          <p:cNvPr id="2" name="Slide Image Placeholder 1"/>
+          <p:cNvSpPr>
+            <a:spLocks noGrp="1" noRot="1" noChangeAspect="1"/>
+          </p:cNvSpPr>
+          <p:nvPr>
+            <p:ph type="sldImg"/>
+          </p:nvPr>
+        </p:nvSpPr>
+        <p:spPr/>
+      </p:sp>
+      <p:sp>
+        <p:nvSpPr>
+          <p:cNvPr id="3" name="Notes Placeholder 2"/>
+          <p:cNvSpPr>
+            <a:spLocks noGrp="1"/>
+          </p:cNvSpPr>
+          <p:nvPr>
+            <p:ph type="body" idx="1"/>
+          </p:nvPr>
+        </p:nvSpPr>
+        <p:spPr/>
+        <p:txBody>
+          <a:bodyPr/>
+          <a:lstStyle/>
+          <a:p>
+            <a:r>
+              <a:t>(1 min) Por indicación del docente, cada riesgo se muestra con su ID del registro de riesgos (documento 15), que no cambia de una semana a otra. Respecto del 23 de octubre bajan tres riesgos que estaban en nivel alto: R-02, el atraso de la integración, porque cumplimos el H6; R-05, Webpay, porque el pago funciona en el ambiente de integración de Transbank; y R-03, la seguridad, por las correcciones del 28 de octubre. Siguen abiertos la app en un teléfono real (R-16), los correos (R-17), el respaldo (R-08) y la ventana para el paso al ambiente UAT (R-15). Sumamos R-18: las pruebas y el ambiente UAT usan la misma base de datos.</a:t>
+            </a:r>
+          </a:p>
+        </p:txBody>
+      </p:sp>
+      <p:sp>
+        <p:nvSpPr>
+          <p:cNvPr id="4" name="Slide Number Placeholder 3"/>
+          <p:cNvSpPr>
+            <a:spLocks noGrp="1"/>
+          </p:cNvSpPr>
+          <p:nvPr>
+            <p:ph type="sldNum" sz="quarter" idx="10"/>
+          </p:nvPr>
+        </p:nvSpPr>
+        <p:spPr/>
+        <p:txBody>
+          <a:bodyPr/>
+          <a:lstStyle/>
+          <a:p>
+            <a:fld id="{F7021451-1387-4CA6-816F-3879F97B5CBC}" type="slidenum">
+              <a:rPr lang="en-US"/>
+              <a:t>12</a:t>
+            </a:fld>
+            <a:endParaRPr lang="en-US"/>
+          </a:p>
+        </p:txBody>
+      </p:sp>
+    </p:spTree>
+    <p:extLst>
+      <p:ext uri="{BB962C8B-B14F-4D97-AF65-F5344CB8AC3E}">
+        <p14:creationId xmlns:p14="http://schemas.microsoft.com/office/powerpoint/2010/main" val="1024086991"/>
+      </p:ext>
+    </p:extLst>
+  </p:cSld>
+  <p:clrMapOvr>
+    <a:masterClrMapping/>
+  </p:clrMapOvr>
+</p:notes>
+</file>
+
 <file path=ppt/notesSlides/notesSlide13.xml><?xml version="1.0" encoding="utf-8"?>
 <p:notes xmlns:a="http://schemas.openxmlformats.org/drawingml/2006/main" xmlns:r="http://schemas.openxmlformats.org/officeDocument/2006/relationships" xmlns:p="http://schemas.openxmlformats.org/presentationml/2006/main">
   <p:cSld>
@@ -555,7 +641,7 @@
           <a:lstStyle/>
           <a:p>
             <a:r>
-              <a:t>(1 min) Por indicación del docente, cada riesgo se muestra con su ID del registro de riesgos (documento 15), que no cambia de una semana a otra. Respecto del 23 de octubre bajan tres riesgos que estaban en nivel alto: R-02, el atraso de la integración, porque cumplimos el H6; R-05, Webpay, porque el pago funciona en el ambiente de integración de Transbank; y R-03, la seguridad, por las correcciones del 28 de octubre. Siguen abiertos la app en un teléfono real (R-16), los correos (R-17), el respaldo (R-08) y la ventana para el paso al ambiente UAT (R-15). Sumamos R-18: las pruebas y el ambiente UAT usan la misma base de datos.</a:t>
+              <a:t>(1 min) Cada riesgo tiene una estrategia, una acción concreta, un responsable y una semana, y conserva su ID. Los de mayor puntaje son la seguridad (R-03), ya mitigada con las correcciones del 28 de octubre, y el respaldo (R-08), que se programa en S13. Esta semana probamos la app en un teléfono real; en S13 dejamos operativos los correos, limpiamos los datos de prueba y firmamos la APK antes del paso al ambiente UAT.</a:t>
             </a:r>
           </a:p>
         </p:txBody>
@@ -641,7 +727,7 @@
           <a:lstStyle/>
           <a:p>
             <a:r>
-              <a:t>(1 min) Cada riesgo tiene una estrategia, una acción concreta, un responsable y una semana, y conserva su ID. Los de mayor puntaje son la seguridad (R-03), ya mitigada con las correcciones del 28 de octubre, y el respaldo (R-08), que se programa en S13. Esta semana probamos la app en un teléfono real; en S13 dejamos operativos los correos, limpiamos los datos de prueba y firmamos la APK antes del paso al ambiente UAT.</a:t>
+              <a:t>(45 s) Esta semana cerramos el sistema integrado y probamos la app en un teléfono real. En S13 dejamos operativos los correos y el respaldo diario, hacemos las pruebas de seguridad y privacidad y preparamos el ambiente UAT con la APK de release; en S14 pasamos al ambiente UAT y entregamos; en S15 ensayamos y en S16 defendemos.</a:t>
             </a:r>
           </a:p>
         </p:txBody>
@@ -727,7 +813,8 @@
           <a:lstStyle/>
           <a:p>
             <a:r>
-              <a:t>(45 s) Esta semana cerramos el sistema integrado y probamos la app en un teléfono real. En S13 dejamos operativos los correos y el respaldo diario, hacemos las pruebas de seguridad y privacidad y preparamos el ambiente UAT con la APK firmada; en S14 pasamos al ambiente UAT y entregamos; en S15 ensayamos y en S16 defendemos.</a:t>
+              <a:rPr lang="en-US" dirty="0"/>
+              <a:t>(30 s) Quedan abiertos tres temas: validar los supuestos con datos reales, cargar la nómina real de barberos y aprobar la fase de despliegue. Gracias; quedamos atentos a sus preguntas.</a:t>
             </a:r>
           </a:p>
         </p:txBody>
@@ -750,93 +837,6 @@
             <a:fld id="{F7021451-1387-4CA6-816F-3879F97B5CBC}" type="slidenum">
               <a:rPr lang="en-US"/>
               <a:t>15</a:t>
-            </a:fld>
-            <a:endParaRPr lang="en-US"/>
-          </a:p>
-        </p:txBody>
-      </p:sp>
-    </p:spTree>
-    <p:extLst>
-      <p:ext uri="{BB962C8B-B14F-4D97-AF65-F5344CB8AC3E}">
-        <p14:creationId xmlns:p14="http://schemas.microsoft.com/office/powerpoint/2010/main" val="1024086991"/>
-      </p:ext>
-    </p:extLst>
-  </p:cSld>
-  <p:clrMapOvr>
-    <a:masterClrMapping/>
-  </p:clrMapOvr>
-</p:notes>
-</file>
-
-<file path=ppt/notesSlides/notesSlide16.xml><?xml version="1.0" encoding="utf-8"?>
-<p:notes xmlns:a="http://schemas.openxmlformats.org/drawingml/2006/main" xmlns:r="http://schemas.openxmlformats.org/officeDocument/2006/relationships" xmlns:p="http://schemas.openxmlformats.org/presentationml/2006/main">
-  <p:cSld>
-    <p:spTree>
-      <p:nvGrpSpPr>
-        <p:cNvPr id="1" name=""/>
-        <p:cNvGrpSpPr/>
-        <p:nvPr/>
-      </p:nvGrpSpPr>
-      <p:grpSpPr>
-        <a:xfrm>
-          <a:off x="0" y="0"/>
-          <a:ext cx="0" cy="0"/>
-          <a:chOff x="0" y="0"/>
-          <a:chExt cx="0" cy="0"/>
-        </a:xfrm>
-      </p:grpSpPr>
-      <p:sp>
-        <p:nvSpPr>
-          <p:cNvPr id="2" name="Slide Image Placeholder 1"/>
-          <p:cNvSpPr>
-            <a:spLocks noGrp="1" noRot="1" noChangeAspect="1"/>
-          </p:cNvSpPr>
-          <p:nvPr>
-            <p:ph type="sldImg"/>
-          </p:nvPr>
-        </p:nvSpPr>
-        <p:spPr/>
-      </p:sp>
-      <p:sp>
-        <p:nvSpPr>
-          <p:cNvPr id="3" name="Notes Placeholder 2"/>
-          <p:cNvSpPr>
-            <a:spLocks noGrp="1"/>
-          </p:cNvSpPr>
-          <p:nvPr>
-            <p:ph type="body" idx="1"/>
-          </p:nvPr>
-        </p:nvSpPr>
-        <p:spPr/>
-        <p:txBody>
-          <a:bodyPr/>
-          <a:lstStyle/>
-          <a:p>
-            <a:r>
-              <a:rPr lang="en-US" dirty="0"/>
-              <a:t>(30 s) Quedan abiertos tres temas: validar los supuestos con datos reales, cargar la nómina real de barberos y aprobar la fase de despliegue. Gracias; quedamos atentos a sus preguntas.</a:t>
-            </a:r>
-          </a:p>
-        </p:txBody>
-      </p:sp>
-      <p:sp>
-        <p:nvSpPr>
-          <p:cNvPr id="4" name="Slide Number Placeholder 3"/>
-          <p:cNvSpPr>
-            <a:spLocks noGrp="1"/>
-          </p:cNvSpPr>
-          <p:nvPr>
-            <p:ph type="sldNum" sz="quarter" idx="10"/>
-          </p:nvPr>
-        </p:nvSpPr>
-        <p:spPr/>
-        <p:txBody>
-          <a:bodyPr/>
-          <a:lstStyle/>
-          <a:p>
-            <a:fld id="{F7021451-1387-4CA6-816F-3879F97B5CBC}" type="slidenum">
-              <a:rPr lang="en-US"/>
-              <a:t>16</a:t>
             </a:fld>
             <a:endParaRPr lang="en-US"/>
           </a:p>
@@ -986,7 +986,7 @@
           <a:lstStyle/>
           <a:p>
             <a:r>
-              <a:t>(1 min) El roadmap completo, desde la semana 1, en su versión al 30 de octubre: se actualiza cada semana. En verde lo realizado: la planificación, el diseño, la API, la presentación de avance (H5) y la integración de esta semana. En amarillo lo que cerramos esta semana: el control de cambios, los diagramas, las pruebas de integración y la web en el ambiente UAT. En azul lo que viene: correcciones, APK firmada, pruebas de seguridad y el paso al ambiente UAT (H7, 10 de noviembre).</a:t>
+              <a:t>(1 min) El roadmap completo, desde la semana 1, en su versión al 30 de octubre: se actualiza cada semana. En verde lo realizado: la planificación, el diseño, la API, la presentación de avance (H5) y la integración de esta semana. En amarillo lo que cerramos esta semana: el control de cambios, los diagramas, las pruebas de integración y la web en el ambiente UAT. En azul lo que viene: correcciones, APK de release, pruebas de seguridad y el paso al ambiente UAT (H7, 10 de noviembre).</a:t>
             </a:r>
           </a:p>
         </p:txBody>
@@ -1072,7 +1072,7 @@
           <a:lstStyle/>
           <a:p>
             <a:r>
-              <a:t>(1 min) El mismo roadmap, desde la semana en curso. Esta semana integramos Webpay, la fila por orden de llegada, «Mis datos» y las cuentas del personal, y corregimos la seguridad de las reservas: es el hito H6. Siguen en curso las pruebas de integración, incluida la app en un teléfono real, y la web ya está publicada en el ambiente UAT. Los correos y el respaldo diario pasan a la semana 13, junto con las correcciones y la APK firmada; en S14 pasamos al ambiente UAT y entregamos.</a:t>
+              <a:t>(1 min) El mismo roadmap, desde la semana en curso. Esta semana integramos Webpay, la fila por orden de llegada, «Mis datos» y las cuentas del personal, y corregimos la seguridad de las reservas: es el hito H6. Siguen en curso las pruebas de integración, incluida la app en un teléfono real, y la web ya está publicada en el ambiente UAT. Los correos y el respaldo diario pasan a la semana 13, junto con las correcciones y la APK de release; en S14 pasamos al ambiente UAT y entregamos.</a:t>
             </a:r>
           </a:p>
         </p:txBody>
@@ -1660,7 +1660,7 @@
           </a:prstGeom>
           <a:extLst>
             <a:ext uri="{C572A759-6A51-4108-AA02-DFA0A04FC94B}">
-              <ma14:wrappingTextBoxFlag xmlns="" xmlns:ma14="http://schemas.microsoft.com/office/mac/drawingml/2011/main" val="0"/>
+              <ma14:wrappingTextBoxFlag xmlns:ma14="http://schemas.microsoft.com/office/mac/drawingml/2011/main" xmlns="" val="0"/>
             </a:ext>
           </a:extLst>
         </p:spPr>
@@ -1771,7 +1771,7 @@
           </a:prstGeom>
           <a:extLst>
             <a:ext uri="{C572A759-6A51-4108-AA02-DFA0A04FC94B}">
-              <ma14:wrappingTextBoxFlag xmlns="" xmlns:ma14="http://schemas.microsoft.com/office/mac/drawingml/2011/main" val="0"/>
+              <ma14:wrappingTextBoxFlag xmlns:ma14="http://schemas.microsoft.com/office/mac/drawingml/2011/main" xmlns="" val="0"/>
             </a:ext>
           </a:extLst>
         </p:spPr>
@@ -2708,7 +2708,7 @@
           <p:nvPr/>
         </p:nvPicPr>
         <p:blipFill>
-          <a:blip r:embed="rId4"/>
+          <a:blip r:embed="rId3"/>
           <a:srcRect/>
           <a:stretch/>
         </p:blipFill>
@@ -3021,7 +3021,51 @@
                 <a:ea typeface="Calibri" pitchFamily="34" charset="-122"/>
                 <a:cs typeface="Calibri" pitchFamily="34" charset="-120"/>
               </a:rPr>
-              <a:t>Documentación de diseño y 35 diagramas (PlantUML y StarUML)</a:t>
+              <a:t>Documentación de diseño y 35 </a:t>
+            </a:r>
+            <a:r>
+              <a:rPr lang="en-US" sz="1200" dirty="0" err="1">
+                <a:solidFill>
+                  <a:srgbClr val="1E2430"/>
+                </a:solidFill>
+                <a:latin typeface="Calibri" pitchFamily="34" charset="0"/>
+                <a:ea typeface="Calibri" pitchFamily="34" charset="-122"/>
+                <a:cs typeface="Calibri" pitchFamily="34" charset="-120"/>
+              </a:rPr>
+              <a:t>diagramas</a:t>
+            </a:r>
+            <a:r>
+              <a:rPr lang="en-US" sz="1200" dirty="0">
+                <a:solidFill>
+                  <a:srgbClr val="1E2430"/>
+                </a:solidFill>
+                <a:latin typeface="Calibri" pitchFamily="34" charset="0"/>
+                <a:ea typeface="Calibri" pitchFamily="34" charset="-122"/>
+                <a:cs typeface="Calibri" pitchFamily="34" charset="-120"/>
+              </a:rPr>
+              <a:t> (</a:t>
+            </a:r>
+            <a:r>
+              <a:rPr lang="en-US" sz="1200" dirty="0" err="1">
+                <a:solidFill>
+                  <a:srgbClr val="1E2430"/>
+                </a:solidFill>
+                <a:latin typeface="Calibri" pitchFamily="34" charset="0"/>
+                <a:ea typeface="Calibri" pitchFamily="34" charset="-122"/>
+                <a:cs typeface="Calibri" pitchFamily="34" charset="-120"/>
+              </a:rPr>
+              <a:t>StarUML</a:t>
+            </a:r>
+            <a:r>
+              <a:rPr lang="en-US" sz="1200" dirty="0">
+                <a:solidFill>
+                  <a:srgbClr val="1E2430"/>
+                </a:solidFill>
+                <a:latin typeface="Calibri" pitchFamily="34" charset="0"/>
+                <a:ea typeface="Calibri" pitchFamily="34" charset="-122"/>
+                <a:cs typeface="Calibri" pitchFamily="34" charset="-120"/>
+              </a:rPr>
+              <a:t>)</a:t>
             </a:r>
             <a:endParaRPr lang="en-US" sz="1200" dirty="0"/>
           </a:p>
@@ -3089,7 +3133,7 @@
           </a:prstGeom>
           <a:extLst>
             <a:ext uri="{C572A759-6A51-4108-AA02-DFA0A04FC94B}">
-              <ma14:wrappingTextBoxFlag xmlns="" xmlns:ma14="http://schemas.microsoft.com/office/mac/drawingml/2011/main" val="0"/>
+              <ma14:wrappingTextBoxFlag xmlns:ma14="http://schemas.microsoft.com/office/mac/drawingml/2011/main" xmlns="" val="0"/>
             </a:ext>
           </a:extLst>
         </p:spPr>
@@ -4026,7 +4070,7 @@
           </a:prstGeom>
           <a:extLst>
             <a:ext uri="{C572A759-6A51-4108-AA02-DFA0A04FC94B}">
-              <ma14:wrappingTextBoxFlag xmlns="" xmlns:ma14="http://schemas.microsoft.com/office/mac/drawingml/2011/main" val="0"/>
+              <ma14:wrappingTextBoxFlag xmlns:ma14="http://schemas.microsoft.com/office/mac/drawingml/2011/main" xmlns="" val="0"/>
             </a:ext>
           </a:extLst>
         </p:spPr>
@@ -4062,7 +4106,7 @@
 </p:sld>
 </file>
 
-<file path=ppt/slides/slide13.xml><?xml version="1.0" encoding="utf-8"?>
+<file path=ppt/slides/slide12.xml><?xml version="1.0" encoding="utf-8"?>
 <p:sld xmlns:a="http://schemas.openxmlformats.org/drawingml/2006/main" xmlns:r="http://schemas.openxmlformats.org/officeDocument/2006/relationships" xmlns:p="http://schemas.openxmlformats.org/presentationml/2006/main">
   <p:cSld name="Slide 13">
     <p:spTree>
@@ -4848,7 +4892,7 @@
           </a:prstGeom>
           <a:extLst>
             <a:ext uri="{C572A759-6A51-4108-AA02-DFA0A04FC94B}">
-              <ma14:wrappingTextBoxFlag xmlns="" xmlns:ma14="http://schemas.microsoft.com/office/mac/drawingml/2011/main" val="0"/>
+              <ma14:wrappingTextBoxFlag xmlns:ma14="http://schemas.microsoft.com/office/mac/drawingml/2011/main" xmlns="" val="0"/>
             </a:ext>
           </a:extLst>
         </p:spPr>
@@ -4870,7 +4914,7 @@
             <a:pPr algn="r"/>
             <a:fld id="{F7021451-1387-4CA6-816F-3879F97B5CBC}" type="slidenum">
               <a:rPr lang="en-US" b="0"/>
-              <a:t>13</a:t>
+              <a:t>12</a:t>
             </a:fld>
             <a:endParaRPr lang="en-US"/>
           </a:p>
@@ -6612,7 +6656,7 @@
 </p:sld>
 </file>
 
-<file path=ppt/slides/slide14.xml><?xml version="1.0" encoding="utf-8"?>
+<file path=ppt/slides/slide13.xml><?xml version="1.0" encoding="utf-8"?>
 <p:sld xmlns:a="http://schemas.openxmlformats.org/drawingml/2006/main" xmlns:r="http://schemas.openxmlformats.org/officeDocument/2006/relationships" xmlns:p="http://schemas.openxmlformats.org/presentationml/2006/main">
   <p:cSld name="Slide 14">
     <p:spTree>
@@ -6762,7 +6806,7 @@
         </p:nvGraphicFramePr>
         <p:xfrm>
           <a:off x="548640" y="1783080"/>
-          <a:ext cx="11064240" cy="4279392"/>
+          <a:ext cx="11064240" cy="4215384"/>
         </p:xfrm>
         <a:graphic>
           <a:graphicData uri="http://schemas.openxmlformats.org/drawingml/2006/table">
@@ -9041,7 +9085,7 @@
                           <a:ea typeface="Calibri" pitchFamily="34" charset="-122"/>
                           <a:cs typeface="Calibri" pitchFamily="34" charset="-120"/>
                         </a:rPr>
-                        <a:t>Web publicada en el ambiente UAT (28-10); APK firmada, lista de verificación y pruebas de humo antes del paso</a:t>
+                        <a:t>Web publicada en el ambiente UAT (28-10); APK de release, lista de verificación y pruebas de humo antes del paso</a:t>
                       </a:r>
                       <a:endParaRPr lang="en-US" sz="1100" dirty="0">
                         <a:latin typeface="Calibri" charset="0"/>
@@ -9524,7 +9568,7 @@
                           <a:ea typeface="Calibri" pitchFamily="34" charset="-122"/>
                           <a:cs typeface="Calibri" pitchFamily="34" charset="-120"/>
                         </a:rPr>
-                        <a:t>APK de prueba lista (28-10); prueba con pago Webpay en un teléfono Android; APK firmada en S13</a:t>
+                        <a:t>APK de prueba lista (28-10); prueba con pago Webpay en un teléfono Android; APK de release en S13</a:t>
                       </a:r>
                       <a:endParaRPr lang="en-US" sz="1100" dirty="0">
                         <a:latin typeface="Calibri" charset="0"/>
@@ -11645,7 +11689,7 @@
                 </a:tc>
                 <a:extLst>
                   <a:ext uri="{0D108BD9-81ED-4DB2-BD59-A6C34878D82A}">
-                    <a16:rowId xmlns:a16="http://schemas.microsoft.com/office/drawing/2014/main" val="10008"/>
+                    <a16:rowId xmlns:a16="http://schemas.microsoft.com/office/drawing/2014/main" val="3970121411"/>
                   </a:ext>
                 </a:extLst>
               </a:tr>
@@ -11673,7 +11717,7 @@
           </a:prstGeom>
           <a:extLst>
             <a:ext uri="{C572A759-6A51-4108-AA02-DFA0A04FC94B}">
-              <ma14:wrappingTextBoxFlag xmlns="" xmlns:ma14="http://schemas.microsoft.com/office/mac/drawingml/2011/main" val="0"/>
+              <ma14:wrappingTextBoxFlag xmlns:ma14="http://schemas.microsoft.com/office/mac/drawingml/2011/main" xmlns="" val="0"/>
             </a:ext>
           </a:extLst>
         </p:spPr>
@@ -11695,7 +11739,7 @@
             <a:pPr algn="r"/>
             <a:fld id="{F7021451-1387-4CA6-816F-3879F97B5CBC}" type="slidenum">
               <a:rPr lang="en-US" b="0"/>
-              <a:t>14</a:t>
+              <a:t>13</a:t>
             </a:fld>
             <a:endParaRPr lang="en-US"/>
           </a:p>
@@ -11709,7 +11753,7 @@
 </p:sld>
 </file>
 
-<file path=ppt/slides/slide15.xml><?xml version="1.0" encoding="utf-8"?>
+<file path=ppt/slides/slide14.xml><?xml version="1.0" encoding="utf-8"?>
 <p:sld xmlns:a="http://schemas.openxmlformats.org/drawingml/2006/main" xmlns:r="http://schemas.openxmlformats.org/officeDocument/2006/relationships" xmlns:p="http://schemas.openxmlformats.org/presentationml/2006/main">
   <p:cSld name="Slide 15">
     <p:spTree>
@@ -12121,7 +12165,7 @@
                 <a:ea typeface="Calibri" pitchFamily="34" charset="-122"/>
                 <a:cs typeface="Calibri" pitchFamily="34" charset="-120"/>
               </a:rPr>
-              <a:t>Correos y respaldo diario · pruebas funcionales, de seguridad y privacidad · despliegue en UAT, APK firmada y limpieza de datos de prueba</a:t>
+              <a:t>Correos y respaldo diario · pruebas funcionales, de seguridad y privacidad · despliegue en UAT, APK de release y limpieza de datos de prueba</a:t>
             </a:r>
             <a:endParaRPr lang="en-US" sz="1300" dirty="0"/>
           </a:p>
@@ -12573,7 +12617,7 @@
           </a:prstGeom>
           <a:extLst>
             <a:ext uri="{C572A759-6A51-4108-AA02-DFA0A04FC94B}">
-              <ma14:wrappingTextBoxFlag xmlns="" xmlns:ma14="http://schemas.microsoft.com/office/mac/drawingml/2011/main" val="0"/>
+              <ma14:wrappingTextBoxFlag xmlns:ma14="http://schemas.microsoft.com/office/mac/drawingml/2011/main" xmlns="" val="0"/>
             </a:ext>
           </a:extLst>
         </p:spPr>
@@ -12595,7 +12639,7 @@
             <a:pPr algn="r"/>
             <a:fld id="{F7021451-1387-4CA6-816F-3879F97B5CBC}" type="slidenum">
               <a:rPr lang="en-US" b="0"/>
-              <a:t>15</a:t>
+              <a:t>14</a:t>
             </a:fld>
             <a:endParaRPr lang="en-US"/>
           </a:p>
@@ -12609,7 +12653,7 @@
 </p:sld>
 </file>
 
-<file path=ppt/slides/slide16.xml><?xml version="1.0" encoding="utf-8"?>
+<file path=ppt/slides/slide15.xml><?xml version="1.0" encoding="utf-8"?>
 <p:sld xmlns:a="http://schemas.openxmlformats.org/drawingml/2006/main" xmlns:r="http://schemas.openxmlformats.org/officeDocument/2006/relationships" xmlns:p="http://schemas.openxmlformats.org/presentationml/2006/main">
   <p:cSld name="Slide 16">
     <p:spTree>
@@ -12766,7 +12810,51 @@
                 <a:ea typeface="Calibri" pitchFamily="34" charset="-122"/>
                 <a:cs typeface="Calibri" pitchFamily="34" charset="-120"/>
               </a:rPr>
-              <a:t>Validar los supuestos de demanda y de duración de los servicios con datos reales de operación.</a:t>
+              <a:t>Validar </a:t>
+            </a:r>
+            <a:r>
+              <a:rPr lang="en-US" sz="1400" dirty="0" err="1">
+                <a:solidFill>
+                  <a:srgbClr val="C3D3E8"/>
+                </a:solidFill>
+                <a:latin typeface="Calibri" pitchFamily="34" charset="0"/>
+                <a:ea typeface="Calibri" pitchFamily="34" charset="-122"/>
+                <a:cs typeface="Calibri" pitchFamily="34" charset="-120"/>
+              </a:rPr>
+              <a:t>los</a:t>
+            </a:r>
+            <a:r>
+              <a:rPr lang="en-US" sz="1400" dirty="0">
+                <a:solidFill>
+                  <a:srgbClr val="C3D3E8"/>
+                </a:solidFill>
+                <a:latin typeface="Calibri" pitchFamily="34" charset="0"/>
+                <a:ea typeface="Calibri" pitchFamily="34" charset="-122"/>
+                <a:cs typeface="Calibri" pitchFamily="34" charset="-120"/>
+              </a:rPr>
+              <a:t> </a:t>
+            </a:r>
+            <a:r>
+              <a:rPr lang="en-US" sz="1400" dirty="0" err="1">
+                <a:solidFill>
+                  <a:srgbClr val="C3D3E8"/>
+                </a:solidFill>
+                <a:latin typeface="Calibri" pitchFamily="34" charset="0"/>
+                <a:ea typeface="Calibri" pitchFamily="34" charset="-122"/>
+                <a:cs typeface="Calibri" pitchFamily="34" charset="-120"/>
+              </a:rPr>
+              <a:t>datos</a:t>
+            </a:r>
+            <a:r>
+              <a:rPr lang="en-US" sz="1400" dirty="0">
+                <a:solidFill>
+                  <a:srgbClr val="C3D3E8"/>
+                </a:solidFill>
+                <a:latin typeface="Calibri" pitchFamily="34" charset="0"/>
+                <a:ea typeface="Calibri" pitchFamily="34" charset="-122"/>
+                <a:cs typeface="Calibri" pitchFamily="34" charset="-120"/>
+              </a:rPr>
+              <a:t> de duración de los servicios con datos reales de operación.</a:t>
             </a:r>
             <a:endParaRPr lang="en-US" sz="1400" dirty="0"/>
           </a:p>
@@ -12787,7 +12875,51 @@
                 <a:ea typeface="Calibri" pitchFamily="34" charset="-122"/>
                 <a:cs typeface="Calibri" pitchFamily="34" charset="-120"/>
               </a:rPr>
-              <a:t>Cargar la nómina real de barberos (hoy hay 4 barberos de prueba).</a:t>
+              <a:t>Cargar la </a:t>
+            </a:r>
+            <a:r>
+              <a:rPr lang="en-US" sz="1400" dirty="0" err="1">
+                <a:solidFill>
+                  <a:srgbClr val="C3D3E8"/>
+                </a:solidFill>
+                <a:latin typeface="Calibri" pitchFamily="34" charset="0"/>
+                <a:ea typeface="Calibri" pitchFamily="34" charset="-122"/>
+                <a:cs typeface="Calibri" pitchFamily="34" charset="-120"/>
+              </a:rPr>
+              <a:t>nómina</a:t>
+            </a:r>
+            <a:r>
+              <a:rPr lang="en-US" sz="1400" dirty="0">
+                <a:solidFill>
+                  <a:srgbClr val="C3D3E8"/>
+                </a:solidFill>
+                <a:latin typeface="Calibri" pitchFamily="34" charset="0"/>
+                <a:ea typeface="Calibri" pitchFamily="34" charset="-122"/>
+                <a:cs typeface="Calibri" pitchFamily="34" charset="-120"/>
+              </a:rPr>
+              <a:t> de </a:t>
+            </a:r>
+            <a:r>
+              <a:rPr lang="en-US" sz="1400" dirty="0" err="1">
+                <a:solidFill>
+                  <a:srgbClr val="C3D3E8"/>
+                </a:solidFill>
+                <a:latin typeface="Calibri" pitchFamily="34" charset="0"/>
+                <a:ea typeface="Calibri" pitchFamily="34" charset="-122"/>
+                <a:cs typeface="Calibri" pitchFamily="34" charset="-120"/>
+              </a:rPr>
+              <a:t>barberos</a:t>
+            </a:r>
+            <a:r>
+              <a:rPr lang="en-US" sz="1400" dirty="0">
+                <a:solidFill>
+                  <a:srgbClr val="C3D3E8"/>
+                </a:solidFill>
+                <a:latin typeface="Calibri" pitchFamily="34" charset="0"/>
+                <a:ea typeface="Calibri" pitchFamily="34" charset="-122"/>
+                <a:cs typeface="Calibri" pitchFamily="34" charset="-120"/>
+              </a:rPr>
+              <a:t>.</a:t>
             </a:r>
             <a:endParaRPr lang="en-US" sz="1400" dirty="0"/>
           </a:p>
@@ -14066,7 +14198,7 @@
                 <a:ea typeface="Calibri" pitchFamily="34" charset="-122"/>
                 <a:cs typeface="Calibri" pitchFamily="34" charset="-120"/>
               </a:rPr>
-              <a:t>Despliegue en UAT y APK firmada (S13) · paso al ambiente UAT (H7, 10-11) · entrega final (H8, 13-11) · defensa (H9, 27-11).</a:t>
+              <a:t>Despliegue en UAT y APK de release (S13) · paso al ambiente UAT (H7, 10-11) · entrega final (H8, 13-11) · defensa (H9, 27-11).</a:t>
             </a:r>
             <a:endParaRPr lang="en-US" sz="1200" dirty="0"/>
           </a:p>
@@ -14092,7 +14224,7 @@
           </a:prstGeom>
           <a:extLst>
             <a:ext uri="{C572A759-6A51-4108-AA02-DFA0A04FC94B}">
-              <ma14:wrappingTextBoxFlag xmlns="" xmlns:ma14="http://schemas.microsoft.com/office/mac/drawingml/2011/main" val="0"/>
+              <ma14:wrappingTextBoxFlag xmlns:ma14="http://schemas.microsoft.com/office/mac/drawingml/2011/main" xmlns="" val="0"/>
             </a:ext>
           </a:extLst>
         </p:spPr>
@@ -15034,7 +15166,7 @@
               <a:buNone/>
             </a:pPr>
             <a:r>
-              <a:rPr lang="en-US" sz="900" dirty="0" b="1">
+              <a:rPr lang="en-US" sz="900" b="1" dirty="0">
                 <a:solidFill>
                   <a:srgbClr val="B83A3A"/>
                 </a:solidFill>
@@ -17594,7 +17726,7 @@
           </a:prstGeom>
           <a:extLst>
             <a:ext uri="{C572A759-6A51-4108-AA02-DFA0A04FC94B}">
-              <ma14:wrappingTextBoxFlag xmlns="" xmlns:ma14="http://schemas.microsoft.com/office/mac/drawingml/2011/main" val="0"/>
+              <ma14:wrappingTextBoxFlag xmlns:ma14="http://schemas.microsoft.com/office/mac/drawingml/2011/main" xmlns="" val="0"/>
             </a:ext>
           </a:extLst>
         </p:spPr>
@@ -17981,7 +18113,7 @@
                 <a:ea typeface="Calibri" pitchFamily="34" charset="-122"/>
                 <a:cs typeface="Calibri" pitchFamily="34" charset="-120"/>
               </a:rPr>
-              <a:t>APK firmada</a:t>
+              <a:t>APK de release</a:t>
             </a:r>
             <a:endParaRPr lang="en-US" sz="850" dirty="0"/>
           </a:p>
@@ -20443,7 +20575,7 @@
                           <a:ea typeface="Calibri" pitchFamily="34" charset="-122"/>
                           <a:cs typeface="Calibri" pitchFamily="34" charset="-120"/>
                         </a:rPr>
-                        <a:t>Despliegue en UAT · APK firmada</a:t>
+                        <a:t>Despliegue en UAT · APK de release</a:t>
                       </a:r>
                       <a:endParaRPr lang="en-US" sz="950" dirty="0">
                         <a:latin typeface="Calibri" charset="0"/>
@@ -21362,7 +21494,7 @@
           </a:prstGeom>
           <a:extLst>
             <a:ext uri="{C572A759-6A51-4108-AA02-DFA0A04FC94B}">
-              <ma14:wrappingTextBoxFlag xmlns="" xmlns:ma14="http://schemas.microsoft.com/office/mac/drawingml/2011/main" val="0"/>
+              <ma14:wrappingTextBoxFlag xmlns:ma14="http://schemas.microsoft.com/office/mac/drawingml/2011/main" xmlns="" val="0"/>
             </a:ext>
           </a:extLst>
         </p:spPr>
@@ -21548,7 +21680,7 @@
         </p:nvGraphicFramePr>
         <p:xfrm>
           <a:off x="548640" y="1783080"/>
-          <a:ext cx="11064240" cy="4215384"/>
+          <a:ext cx="11064240" cy="4247388"/>
         </p:xfrm>
         <a:graphic>
           <a:graphicData uri="http://schemas.openxmlformats.org/drawingml/2006/table">
@@ -23561,7 +23693,7 @@
           </a:prstGeom>
           <a:extLst>
             <a:ext uri="{C572A759-6A51-4108-AA02-DFA0A04FC94B}">
-              <ma14:wrappingTextBoxFlag xmlns="" xmlns:ma14="http://schemas.microsoft.com/office/mac/drawingml/2011/main" val="0"/>
+              <ma14:wrappingTextBoxFlag xmlns:ma14="http://schemas.microsoft.com/office/mac/drawingml/2011/main" xmlns="" val="0"/>
             </a:ext>
           </a:extLst>
         </p:spPr>
@@ -24416,7 +24548,7 @@
           </a:prstGeom>
           <a:extLst>
             <a:ext uri="{C572A759-6A51-4108-AA02-DFA0A04FC94B}">
-              <ma14:wrappingTextBoxFlag xmlns="" xmlns:ma14="http://schemas.microsoft.com/office/mac/drawingml/2011/main" val="0"/>
+              <ma14:wrappingTextBoxFlag xmlns:ma14="http://schemas.microsoft.com/office/mac/drawingml/2011/main" xmlns="" val="0"/>
             </a:ext>
           </a:extLst>
         </p:spPr>
@@ -26519,7 +26651,7 @@
           </a:prstGeom>
           <a:extLst>
             <a:ext uri="{C572A759-6A51-4108-AA02-DFA0A04FC94B}">
-              <ma14:wrappingTextBoxFlag xmlns="" xmlns:ma14="http://schemas.microsoft.com/office/mac/drawingml/2011/main" val="0"/>
+              <ma14:wrappingTextBoxFlag xmlns:ma14="http://schemas.microsoft.com/office/mac/drawingml/2011/main" xmlns="" val="0"/>
             </a:ext>
           </a:extLst>
         </p:spPr>
@@ -27215,7 +27347,7 @@
           </a:prstGeom>
           <a:extLst>
             <a:ext uri="{C572A759-6A51-4108-AA02-DFA0A04FC94B}">
-              <ma14:wrappingTextBoxFlag xmlns="" xmlns:ma14="http://schemas.microsoft.com/office/mac/drawingml/2011/main" val="0"/>
+              <ma14:wrappingTextBoxFlag xmlns:ma14="http://schemas.microsoft.com/office/mac/drawingml/2011/main" xmlns="" val="0"/>
             </a:ext>
           </a:extLst>
         </p:spPr>
@@ -27852,7 +27984,7 @@
           </a:prstGeom>
           <a:extLst>
             <a:ext uri="{C572A759-6A51-4108-AA02-DFA0A04FC94B}">
-              <ma14:wrappingTextBoxFlag xmlns="" xmlns:ma14="http://schemas.microsoft.com/office/mac/drawingml/2011/main" val="0"/>
+              <ma14:wrappingTextBoxFlag xmlns:ma14="http://schemas.microsoft.com/office/mac/drawingml/2011/main" xmlns="" val="0"/>
             </a:ext>
           </a:extLst>
         </p:spPr>

</xml_diff>